<commit_message>
Replace runner artwork with a sculpted sprinter; refine weightlifter
The sprinter is redrawn mid-drive out of the blocks from muscle-shaped
ellipses fused into one smooth outline, with rim light, soft shading,
a motion blur and a ground shadow. The weightlifter gets the same finish.

Co-Authored-By: Claude Opus 5.5 <noreply@anthropic.com>
Claude-Session: https://claude.ai/code/session_01CSkzjv2pUKWCAnTTv8qteA
</commit_message>
<xml_diff>
--- a/dhruv-athlete-healthcheck/Dhruv_Athlete_Checkup_Gym_Partner_Deck.pptx
+++ b/dhruv-athlete-healthcheck/Dhruv_Athlete_Checkup_Gym_Partner_Deck.pptx
@@ -117,32 +117,32 @@
   <p:extLst>
     <p:ext uri="{521415D9-36F7-43E2-AB2F-B90AF26B5E84}">
       <p14:sectionLst xmlns:p14="http://schemas.microsoft.com/office/powerpoint/2010/main">
-        <p14:section name="Opening" id="{d8aa9af1-26a9-f5fc-a825-cf4094b72107}">
+        <p14:section name="Opening" id="{133ebb22-4312-c61e-b8d8-9a03915eaa49}">
           <p14:sldIdLst>
             <p14:sldId id="256"/>
           </p14:sldIdLst>
         </p14:section>
-        <p14:section name="Why" id="{17a02386-0501-f887-4f47-db4cea7071fa}">
+        <p14:section name="Why" id="{23847716-2a3c-a9e4-c84d-ad298c974d4d}">
           <p14:sldIdLst>
             <p14:sldId id="257"/>
             <p14:sldId id="258"/>
           </p14:sldIdLst>
         </p14:section>
-        <p14:section name="Offer" id="{7ed601a6-e208-ad63-23a5-f7c8ed0ff3a7}">
+        <p14:section name="Offer" id="{ca692a67-78d9-3378-a129-5f725f3de4a1}">
           <p14:sldIdLst>
             <p14:sldId id="259"/>
             <p14:sldId id="260"/>
             <p14:sldId id="261"/>
           </p14:sldIdLst>
         </p14:section>
-        <p14:section name="Partnership" id="{4e9d16ca-229d-2c03-10c9-815bad178e1f}">
+        <p14:section name="Partnership" id="{edb329a1-6ea3-3951-c5f2-037052e34041}">
           <p14:sldIdLst>
             <p14:sldId id="262"/>
             <p14:sldId id="263"/>
             <p14:sldId id="264"/>
           </p14:sldIdLst>
         </p14:section>
-        <p14:section name="Booking" id="{b0d1d989-78ef-e007-229d-ec9a5f9c687a}">
+        <p14:section name="Booking" id="{653b2570-0a0b-b016-afff-ea86cfc31ce2}">
           <p14:sldIdLst>
             <p14:sldId id="265"/>
             <p14:sldId id="266"/>

</xml_diff>

<commit_message>
Use the Dhruv DNA helix as logo mark and hero artwork
Redraws the double-helix mark as vector artwork (purple ribbons, two-tone
rungs, gold, navy, magenta and blue spheres) and places it beside the
wordmark on covers, closing slides, slide footers and the flyer. The helix
replaces the runner on the covers, the flyer header and two promo panels.

Co-Authored-By: Claude Opus 5.5 <noreply@anthropic.com>
Claude-Session: https://claude.ai/code/session_01CSkzjv2pUKWCAnTTv8qteA
</commit_message>
<xml_diff>
--- a/dhruv-athlete-healthcheck/Dhruv_Athlete_Checkup_Gym_Partner_Deck.pptx
+++ b/dhruv-athlete-healthcheck/Dhruv_Athlete_Checkup_Gym_Partner_Deck.pptx
@@ -117,32 +117,32 @@
   <p:extLst>
     <p:ext uri="{521415D9-36F7-43E2-AB2F-B90AF26B5E84}">
       <p14:sectionLst xmlns:p14="http://schemas.microsoft.com/office/powerpoint/2010/main">
-        <p14:section name="Opening" id="{133ebb22-4312-c61e-b8d8-9a03915eaa49}">
+        <p14:section name="Opening" id="{1b12a47b-46c3-e38c-10b5-e748fe3c0f3c}">
           <p14:sldIdLst>
             <p14:sldId id="256"/>
           </p14:sldIdLst>
         </p14:section>
-        <p14:section name="Why" id="{23847716-2a3c-a9e4-c84d-ad298c974d4d}">
+        <p14:section name="Why" id="{e1ab0044-9803-de13-a39d-427af252a6f9}">
           <p14:sldIdLst>
             <p14:sldId id="257"/>
             <p14:sldId id="258"/>
           </p14:sldIdLst>
         </p14:section>
-        <p14:section name="Offer" id="{ca692a67-78d9-3378-a129-5f725f3de4a1}">
+        <p14:section name="Offer" id="{5b5b1f8e-026e-6103-03af-c1bc95a19c43}">
           <p14:sldIdLst>
             <p14:sldId id="259"/>
             <p14:sldId id="260"/>
             <p14:sldId id="261"/>
           </p14:sldIdLst>
         </p14:section>
-        <p14:section name="Partnership" id="{edb329a1-6ea3-3951-c5f2-037052e34041}">
+        <p14:section name="Partnership" id="{2a20a4c0-4c8c-69b4-12d0-5941935bfa71}">
           <p14:sldIdLst>
             <p14:sldId id="262"/>
             <p14:sldId id="263"/>
             <p14:sldId id="264"/>
           </p14:sldIdLst>
         </p14:section>
-        <p14:section name="Booking" id="{653b2570-0a0b-b016-afff-ea86cfc31ce2}">
+        <p14:section name="Booking" id="{0335fb84-4014-4783-802b-b95939b2262e}">
           <p14:sldIdLst>
             <p14:sldId id="265"/>
             <p14:sldId id="266"/>
@@ -1602,16 +1602,40 @@
           </a:p>
         </p:txBody>
       </p:sp>
-      <p:sp>
-        <p:nvSpPr>
-          <p:cNvPr id="3" name="Text 0"/>
+      <p:pic>
+        <p:nvPicPr>
+          <p:cNvPr id="3" name="Image 0" descr="/tmp/claude-0/-home-user-BlisteringBlockchain/d9fb2d6e-0573-5890-9b54-a37c96abb606/scratchpad/art/logo_mark.png">    </p:cNvPr>
+          <p:cNvPicPr>
+            <a:picLocks noChangeAspect="1"/>
+          </p:cNvPicPr>
+          <p:nvPr/>
+        </p:nvPicPr>
+        <p:blipFill>
+          <a:blip r:embed="rId1"/>
+          <a:stretch>
+            <a:fillRect/>
+          </a:stretch>
+        </p:blipFill>
+        <p:spPr>
+          <a:xfrm>
+            <a:off x="457200" y="4709160"/>
+            <a:ext cx="246888" cy="306324"/>
+          </a:xfrm>
+          <a:prstGeom prst="rect">
+            <a:avLst/>
+          </a:prstGeom>
+        </p:spPr>
+      </p:pic>
+      <p:sp>
+        <p:nvSpPr>
+          <p:cNvPr id="4" name="Text 0"/>
           <p:cNvSpPr/>
           <p:nvPr/>
         </p:nvSpPr>
         <p:spPr>
           <a:xfrm>
-            <a:off x="457200" y="4773168"/>
-            <a:ext cx="5943600" cy="201168"/>
+            <a:off x="786384" y="4773168"/>
+            <a:ext cx="5669280" cy="201168"/>
           </a:xfrm>
           <a:prstGeom prst="rect">
             <a:avLst/>
@@ -2046,15 +2070,39 @@
           <a:chExt cx="0" cy="0"/>
         </a:xfrm>
       </p:grpSpPr>
-      <p:sp>
-        <p:nvSpPr>
-          <p:cNvPr id="2" name="Text 0"/>
-          <p:cNvSpPr txBox="1"/>
-          <p:nvPr/>
-        </p:nvSpPr>
-        <p:spPr>
-          <a:xfrm>
-            <a:off x="548640" y="457200"/>
+      <p:pic>
+        <p:nvPicPr>
+          <p:cNvPr id="2" name="Image 0" descr="Dhruv Diagnostics logo">    </p:cNvPr>
+          <p:cNvPicPr>
+            <a:picLocks noChangeAspect="1"/>
+          </p:cNvPicPr>
+          <p:nvPr/>
+        </p:nvPicPr>
+        <p:blipFill>
+          <a:blip r:embed="rId2"/>
+          <a:stretch>
+            <a:fillRect/>
+          </a:stretch>
+        </p:blipFill>
+        <p:spPr>
+          <a:xfrm>
+            <a:off x="548640" y="367881"/>
+            <a:ext cx="599923" cy="744322"/>
+          </a:xfrm>
+          <a:prstGeom prst="rect">
+            <a:avLst/>
+          </a:prstGeom>
+        </p:spPr>
+      </p:pic>
+      <p:sp>
+        <p:nvSpPr>
+          <p:cNvPr id="3" name="Text 0"/>
+          <p:cNvSpPr txBox="1"/>
+          <p:nvPr/>
+        </p:nvSpPr>
+        <p:spPr>
+          <a:xfrm>
+            <a:off x="1267435" y="457200"/>
             <a:ext cx="2743200" cy="731520"/>
           </a:xfrm>
           <a:prstGeom prst="rect">
@@ -2098,7 +2146,7 @@
       </p:sp>
       <p:sp>
         <p:nvSpPr>
-          <p:cNvPr id="3" name="Text 1"/>
+          <p:cNvPr id="4" name="Text 1"/>
           <p:cNvSpPr txBox="1"/>
           <p:nvPr/>
         </p:nvSpPr>
@@ -2134,7 +2182,7 @@
       </p:sp>
       <p:sp>
         <p:nvSpPr>
-          <p:cNvPr id="4" name="Text 2"/>
+          <p:cNvPr id="5" name="Text 2"/>
           <p:cNvSpPr txBox="1"/>
           <p:nvPr/>
         </p:nvSpPr>
@@ -2170,7 +2218,7 @@
       </p:sp>
       <p:sp>
         <p:nvSpPr>
-          <p:cNvPr id="5" name="Text 3"/>
+          <p:cNvPr id="6" name="Text 3"/>
           <p:cNvSpPr txBox="1"/>
           <p:nvPr/>
         </p:nvSpPr>
@@ -2833,15 +2881,39 @@
           <a:chExt cx="0" cy="0"/>
         </a:xfrm>
       </p:grpSpPr>
-      <p:sp>
-        <p:nvSpPr>
-          <p:cNvPr id="2" name="Text 0"/>
-          <p:cNvSpPr txBox="1"/>
-          <p:nvPr/>
-        </p:nvSpPr>
-        <p:spPr>
-          <a:xfrm>
-            <a:off x="548640" y="411480"/>
+      <p:pic>
+        <p:nvPicPr>
+          <p:cNvPr id="2" name="Image 0" descr="Dhruv Diagnostics logo">    </p:cNvPr>
+          <p:cNvPicPr>
+            <a:picLocks noChangeAspect="1"/>
+          </p:cNvPicPr>
+          <p:nvPr/>
+        </p:nvPicPr>
+        <p:blipFill>
+          <a:blip r:embed="rId2"/>
+          <a:stretch>
+            <a:fillRect/>
+          </a:stretch>
+        </p:blipFill>
+        <p:spPr>
+          <a:xfrm>
+            <a:off x="548640" y="338401"/>
+            <a:ext cx="490846" cy="608990"/>
+          </a:xfrm>
+          <a:prstGeom prst="rect">
+            <a:avLst/>
+          </a:prstGeom>
+        </p:spPr>
+      </p:pic>
+      <p:sp>
+        <p:nvSpPr>
+          <p:cNvPr id="3" name="Text 0"/>
+          <p:cNvSpPr txBox="1"/>
+          <p:nvPr/>
+        </p:nvSpPr>
+        <p:spPr>
+          <a:xfrm>
+            <a:off x="1158358" y="411480"/>
             <a:ext cx="2743200" cy="731520"/>
           </a:xfrm>
           <a:prstGeom prst="rect">
@@ -2885,7 +2957,7 @@
       </p:sp>
       <p:sp>
         <p:nvSpPr>
-          <p:cNvPr id="3" name="Text 1"/>
+          <p:cNvPr id="4" name="Text 1"/>
           <p:cNvSpPr txBox="1"/>
           <p:nvPr/>
         </p:nvSpPr>
@@ -2921,7 +2993,7 @@
       </p:sp>
       <p:sp>
         <p:nvSpPr>
-          <p:cNvPr id="4" name="Text 2"/>
+          <p:cNvPr id="5" name="Text 2"/>
           <p:cNvSpPr txBox="1"/>
           <p:nvPr/>
         </p:nvSpPr>
@@ -2968,7 +3040,7 @@
       </p:sp>
       <p:sp>
         <p:nvSpPr>
-          <p:cNvPr id="5" name="Text 3"/>
+          <p:cNvPr id="6" name="Text 3"/>
           <p:cNvSpPr txBox="1"/>
           <p:nvPr/>
         </p:nvSpPr>
@@ -3004,7 +3076,7 @@
       </p:sp>
       <p:sp>
         <p:nvSpPr>
-          <p:cNvPr id="6" name="Text 4"/>
+          <p:cNvPr id="7" name="Text 4"/>
           <p:cNvSpPr txBox="1"/>
           <p:nvPr/>
         </p:nvSpPr>
@@ -3051,7 +3123,7 @@
       </p:sp>
       <p:sp>
         <p:nvSpPr>
-          <p:cNvPr id="7" name="Text 5"/>
+          <p:cNvPr id="8" name="Text 5"/>
           <p:cNvSpPr txBox="1"/>
           <p:nvPr/>
         </p:nvSpPr>
@@ -3087,7 +3159,7 @@
       </p:sp>
       <p:sp>
         <p:nvSpPr>
-          <p:cNvPr id="8" name="Text 6"/>
+          <p:cNvPr id="9" name="Text 6"/>
           <p:cNvSpPr txBox="1"/>
           <p:nvPr/>
         </p:nvSpPr>
@@ -3123,7 +3195,7 @@
       </p:sp>
       <p:sp>
         <p:nvSpPr>
-          <p:cNvPr id="9" name="Shape 7"/>
+          <p:cNvPr id="10" name="Shape 7"/>
           <p:cNvSpPr/>
           <p:nvPr/>
         </p:nvSpPr>
@@ -3148,14 +3220,14 @@
       </p:sp>
       <p:pic>
         <p:nvPicPr>
-          <p:cNvPr id="10" name="Image 0" descr="Website QR code">    </p:cNvPr>
+          <p:cNvPr id="11" name="Image 1" descr="Website QR code">    </p:cNvPr>
           <p:cNvPicPr>
             <a:picLocks noChangeAspect="1"/>
           </p:cNvPicPr>
           <p:nvPr/>
         </p:nvPicPr>
         <p:blipFill>
-          <a:blip r:embed="rId2"/>
+          <a:blip r:embed="rId3"/>
           <a:stretch>
             <a:fillRect/>
           </a:stretch>
@@ -3172,7 +3244,7 @@
       </p:pic>
       <p:sp>
         <p:nvSpPr>
-          <p:cNvPr id="11" name="Text 8"/>
+          <p:cNvPr id="12" name="Text 8"/>
           <p:cNvSpPr txBox="1"/>
           <p:nvPr/>
         </p:nvSpPr>
@@ -3208,7 +3280,7 @@
       </p:sp>
       <p:sp>
         <p:nvSpPr>
-          <p:cNvPr id="12" name="Shape 9"/>
+          <p:cNvPr id="13" name="Shape 9"/>
           <p:cNvSpPr/>
           <p:nvPr/>
         </p:nvSpPr>
@@ -3233,14 +3305,14 @@
       </p:sp>
       <p:pic>
         <p:nvPicPr>
-          <p:cNvPr id="13" name="Image 1" descr="Laxmi Nagar map QR code">    </p:cNvPr>
+          <p:cNvPr id="14" name="Image 2" descr="Laxmi Nagar map QR code">    </p:cNvPr>
           <p:cNvPicPr>
             <a:picLocks noChangeAspect="1"/>
           </p:cNvPicPr>
           <p:nvPr/>
         </p:nvPicPr>
         <p:blipFill>
-          <a:blip r:embed="rId3"/>
+          <a:blip r:embed="rId4"/>
           <a:stretch>
             <a:fillRect/>
           </a:stretch>
@@ -3257,7 +3329,7 @@
       </p:pic>
       <p:sp>
         <p:nvSpPr>
-          <p:cNvPr id="14" name="Text 10"/>
+          <p:cNvPr id="15" name="Text 10"/>
           <p:cNvSpPr txBox="1"/>
           <p:nvPr/>
         </p:nvSpPr>
@@ -3293,7 +3365,7 @@
       </p:sp>
       <p:sp>
         <p:nvSpPr>
-          <p:cNvPr id="15" name="Shape 11"/>
+          <p:cNvPr id="16" name="Shape 11"/>
           <p:cNvSpPr/>
           <p:nvPr/>
         </p:nvSpPr>
@@ -3318,14 +3390,14 @@
       </p:sp>
       <p:pic>
         <p:nvPicPr>
-          <p:cNvPr id="16" name="Image 2" descr="Ramdaspeth map QR code">    </p:cNvPr>
+          <p:cNvPr id="17" name="Image 3" descr="Ramdaspeth map QR code">    </p:cNvPr>
           <p:cNvPicPr>
             <a:picLocks noChangeAspect="1"/>
           </p:cNvPicPr>
           <p:nvPr/>
         </p:nvPicPr>
         <p:blipFill>
-          <a:blip r:embed="rId4"/>
+          <a:blip r:embed="rId5"/>
           <a:stretch>
             <a:fillRect/>
           </a:stretch>
@@ -3342,7 +3414,7 @@
       </p:pic>
       <p:sp>
         <p:nvSpPr>
-          <p:cNvPr id="17" name="Text 12"/>
+          <p:cNvPr id="18" name="Text 12"/>
           <p:cNvSpPr txBox="1"/>
           <p:nvPr/>
         </p:nvSpPr>
@@ -3943,7 +4015,7 @@
       </p:sp>
       <p:pic>
         <p:nvPicPr>
-          <p:cNvPr id="3" name="Image 0" descr="Illustration of a sprinter">    </p:cNvPr>
+          <p:cNvPr id="3" name="Image 0" descr="DNA double helix illustration">    </p:cNvPr>
           <p:cNvPicPr>
             <a:picLocks noChangeAspect="1"/>
           </p:cNvPicPr>
@@ -6978,7 +7050,7 @@
       </p:sp>
       <p:pic>
         <p:nvPicPr>
-          <p:cNvPr id="3" name="Image 0" descr="Illustration of a sprinter">    </p:cNvPr>
+          <p:cNvPr id="3" name="Image 0" descr="DNA double helix illustration">    </p:cNvPr>
           <p:cNvPicPr>
             <a:picLocks noChangeAspect="1"/>
           </p:cNvPicPr>

</xml_diff>

<commit_message>
Add prices to the three plans
Base Rs 2,999, Performance Rs 8,999, Elite Rs 12,999, with 10% off for
gym-partner members and add-on prices, set from verified 2026 Nagpur and
national test prices and a 36-package market benchmark. Prices appear on
the promo plans slide, the technical plan table and the flyer; the
research and calculation are saved under pricing/.

Co-Authored-By: Claude Opus 5.5 <noreply@anthropic.com>
Claude-Session: https://claude.ai/code/session_01CSkzjv2pUKWCAnTTv8qteA
</commit_message>
<xml_diff>
--- a/dhruv-athlete-healthcheck/Dhruv_Athlete_Checkup_Gym_Partner_Deck.pptx
+++ b/dhruv-athlete-healthcheck/Dhruv_Athlete_Checkup_Gym_Partner_Deck.pptx
@@ -117,32 +117,32 @@
   <p:extLst>
     <p:ext uri="{521415D9-36F7-43E2-AB2F-B90AF26B5E84}">
       <p14:sectionLst xmlns:p14="http://schemas.microsoft.com/office/powerpoint/2010/main">
-        <p14:section name="Opening" id="{1b12a47b-46c3-e38c-10b5-e748fe3c0f3c}">
+        <p14:section name="Opening" id="{185be187-7ebd-66ec-14f5-edaf44842fde}">
           <p14:sldIdLst>
             <p14:sldId id="256"/>
           </p14:sldIdLst>
         </p14:section>
-        <p14:section name="Why" id="{e1ab0044-9803-de13-a39d-427af252a6f9}">
+        <p14:section name="Why" id="{aafa37d6-56c5-63f1-154d-1b532d402c54}">
           <p14:sldIdLst>
             <p14:sldId id="257"/>
             <p14:sldId id="258"/>
           </p14:sldIdLst>
         </p14:section>
-        <p14:section name="Offer" id="{5b5b1f8e-026e-6103-03af-c1bc95a19c43}">
+        <p14:section name="Offer" id="{51d32974-f81a-8aa9-9cc3-6ca792ede22c}">
           <p14:sldIdLst>
             <p14:sldId id="259"/>
             <p14:sldId id="260"/>
             <p14:sldId id="261"/>
           </p14:sldIdLst>
         </p14:section>
-        <p14:section name="Partnership" id="{2a20a4c0-4c8c-69b4-12d0-5941935bfa71}">
+        <p14:section name="Partnership" id="{1b429cf3-90e6-cac9-51d4-5ded612e5edd}">
           <p14:sldIdLst>
             <p14:sldId id="262"/>
             <p14:sldId id="263"/>
             <p14:sldId id="264"/>
           </p14:sldIdLst>
         </p14:section>
-        <p14:section name="Booking" id="{0335fb84-4014-4783-802b-b95939b2262e}">
+        <p14:section name="Booking" id="{6077887d-6666-a5eb-2ff5-33c9bdfbd575}">
           <p14:sldIdLst>
             <p14:sldId id="265"/>
             <p14:sldId id="266"/>
@@ -1168,7 +1168,7 @@
           <a:p>
             <a:r>
               <a:rPr lang="en-US" dirty="0"/>
-              <a:t>Fill in partner prices before the meeting. A urine drugs-of-abuse screen can be added to any plan.</a:t>
+              <a:t>Prices are proposed launch prices set from 2026 market rates for each test in Nagpur and national chains; the struck-through figure is the sum of the same tests bought one by one. Confirm with Dhruv management before external use.</a:t>
             </a:r>
             <a:endParaRPr lang="en-US" dirty="0"/>
           </a:p>
@@ -5549,7 +5549,7 @@
         <p:spPr>
           <a:xfrm>
             <a:off x="457200" y="1051560"/>
-            <a:ext cx="2606040" cy="3520440"/>
+            <a:ext cx="2606040" cy="3310128"/>
           </a:xfrm>
           <a:prstGeom prst="rect">
             <a:avLst/>
@@ -5573,31 +5573,31 @@
         </p:nvSpPr>
         <p:spPr>
           <a:xfrm>
-            <a:off x="658368" y="1207008"/>
-            <a:ext cx="2240280" cy="411480"/>
-          </a:xfrm>
-          <a:prstGeom prst="rect">
-            <a:avLst/>
-          </a:prstGeom>
-          <a:noFill/>
-          <a:ln/>
-        </p:spPr>
-        <p:txBody>
-          <a:bodyPr wrap="square" lIns="0" tIns="0" rIns="0" bIns="0" rtlCol="0" anchor="t"/>
-          <a:lstStyle/>
-          <a:p>
-            <a:pPr indent="0" marL="0">
-              <a:buNone/>
-            </a:pPr>
-            <a:r>
-              <a:rPr lang="en-US" sz="2200" b="1" dirty="0">
+            <a:off x="658368" y="1188720"/>
+            <a:ext cx="2240280" cy="384048"/>
+          </a:xfrm>
+          <a:prstGeom prst="rect">
+            <a:avLst/>
+          </a:prstGeom>
+          <a:noFill/>
+          <a:ln/>
+        </p:spPr>
+        <p:txBody>
+          <a:bodyPr wrap="square" lIns="0" tIns="0" rIns="0" bIns="0" rtlCol="0" anchor="t"/>
+          <a:lstStyle/>
+          <a:p>
+            <a:pPr indent="0" marL="0">
+              <a:buNone/>
+            </a:pPr>
+            <a:r>
+              <a:rPr lang="en-US" sz="2100" b="1" dirty="0">
                 <a:solidFill>
                   <a:srgbClr val="1B2A4A"/>
                 </a:solidFill>
               </a:rPr>
               <a:t>Base</a:t>
             </a:r>
-            <a:endParaRPr lang="en-US" sz="2200" dirty="0"/>
+            <a:endParaRPr lang="en-US" sz="2100" dirty="0"/>
           </a:p>
         </p:txBody>
       </p:sp>
@@ -5609,31 +5609,31 @@
         </p:nvSpPr>
         <p:spPr>
           <a:xfrm>
-            <a:off x="658368" y="1664208"/>
-            <a:ext cx="2240280" cy="685800"/>
-          </a:xfrm>
-          <a:prstGeom prst="rect">
-            <a:avLst/>
-          </a:prstGeom>
-          <a:noFill/>
-          <a:ln/>
-        </p:spPr>
-        <p:txBody>
-          <a:bodyPr wrap="square" lIns="0" tIns="0" rIns="0" bIns="0" rtlCol="0" anchor="t"/>
-          <a:lstStyle/>
-          <a:p>
-            <a:pPr indent="0" marL="0">
-              <a:buNone/>
-            </a:pPr>
-            <a:r>
-              <a:rPr lang="en-US" sz="1200" i="1" dirty="0">
+            <a:off x="658368" y="1591056"/>
+            <a:ext cx="2240280" cy="566928"/>
+          </a:xfrm>
+          <a:prstGeom prst="rect">
+            <a:avLst/>
+          </a:prstGeom>
+          <a:noFill/>
+          <a:ln/>
+        </p:spPr>
+        <p:txBody>
+          <a:bodyPr wrap="square" lIns="0" tIns="0" rIns="0" bIns="0" rtlCol="0" anchor="t"/>
+          <a:lstStyle/>
+          <a:p>
+            <a:pPr indent="0" marL="0">
+              <a:buNone/>
+            </a:pPr>
+            <a:r>
+              <a:rPr lang="en-US" sz="1100" i="1" dirty="0">
                 <a:solidFill>
                   <a:srgbClr val="475569"/>
                 </a:solidFill>
               </a:rPr>
               <a:t>Members starting out or under 35</a:t>
             </a:r>
-            <a:endParaRPr lang="en-US" sz="1200" dirty="0"/>
+            <a:endParaRPr lang="en-US" sz="1100" dirty="0"/>
           </a:p>
         </p:txBody>
       </p:sp>
@@ -5645,8 +5645,8 @@
         </p:nvSpPr>
         <p:spPr>
           <a:xfrm>
-            <a:off x="658368" y="2377440"/>
-            <a:ext cx="2240280" cy="1600200"/>
+            <a:off x="658368" y="2194560"/>
+            <a:ext cx="2240280" cy="1234440"/>
           </a:xfrm>
           <a:prstGeom prst="rect">
             <a:avLst/>
@@ -5660,56 +5660,56 @@
           <a:p>
             <a:pPr marL="342900" indent="-342900">
               <a:spcAft>
-                <a:spcPts val="400"/>
+                <a:spcPts val="300"/>
               </a:spcAft>
               <a:buSzPct val="100000"/>
               <a:buChar char="•"/>
             </a:pPr>
             <a:r>
-              <a:rPr lang="en-US" sz="1300" dirty="0">
+              <a:rPr lang="en-US" sz="1200" dirty="0">
                 <a:solidFill>
                   <a:srgbClr val="1B2A4A"/>
                 </a:solidFill>
               </a:rPr>
               <a:t>Full blood panel and ECG</a:t>
             </a:r>
-            <a:endParaRPr lang="en-US" sz="1300" dirty="0"/>
+            <a:endParaRPr lang="en-US" sz="1200" dirty="0"/>
           </a:p>
           <a:p>
             <a:pPr marL="342900" indent="-342900">
               <a:spcAft>
-                <a:spcPts val="400"/>
+                <a:spcPts val="300"/>
               </a:spcAft>
               <a:buSzPct val="100000"/>
               <a:buChar char="•"/>
             </a:pPr>
             <a:r>
-              <a:rPr lang="en-US" sz="1300" dirty="0">
+              <a:rPr lang="en-US" sz="1200" dirty="0">
                 <a:solidFill>
                   <a:srgbClr val="1B2A4A"/>
                 </a:solidFill>
               </a:rPr>
               <a:t>CK muscle marker</a:t>
             </a:r>
-            <a:endParaRPr lang="en-US" sz="1300" dirty="0"/>
+            <a:endParaRPr lang="en-US" sz="1200" dirty="0"/>
           </a:p>
           <a:p>
             <a:pPr marL="342900" indent="-342900">
               <a:spcAft>
-                <a:spcPts val="400"/>
+                <a:spcPts val="300"/>
               </a:spcAft>
               <a:buSzPct val="100000"/>
               <a:buChar char="•"/>
             </a:pPr>
             <a:r>
-              <a:rPr lang="en-US" sz="1300" dirty="0">
+              <a:rPr lang="en-US" sz="1200" dirty="0">
                 <a:solidFill>
                   <a:srgbClr val="1B2A4A"/>
                 </a:solidFill>
               </a:rPr>
               <a:t>Physician review</a:t>
             </a:r>
-            <a:endParaRPr lang="en-US" sz="1300" dirty="0"/>
+            <a:endParaRPr lang="en-US" sz="1200" dirty="0"/>
           </a:p>
         </p:txBody>
       </p:sp>
@@ -5721,44 +5721,127 @@
         </p:nvSpPr>
         <p:spPr>
           <a:xfrm>
-            <a:off x="658368" y="4160520"/>
-            <a:ext cx="2240280" cy="274320"/>
-          </a:xfrm>
-          <a:prstGeom prst="rect">
-            <a:avLst/>
-          </a:prstGeom>
-          <a:noFill/>
-          <a:ln/>
-        </p:spPr>
-        <p:txBody>
-          <a:bodyPr wrap="square" lIns="0" tIns="0" rIns="0" bIns="0" rtlCol="0" anchor="t"/>
-          <a:lstStyle/>
-          <a:p>
-            <a:pPr indent="0" marL="0">
-              <a:buNone/>
-            </a:pPr>
-            <a:r>
-              <a:rPr lang="en-US" sz="1200" b="1" dirty="0">
+            <a:off x="658368" y="3291840"/>
+            <a:ext cx="2240280" cy="457200"/>
+          </a:xfrm>
+          <a:prstGeom prst="rect">
+            <a:avLst/>
+          </a:prstGeom>
+          <a:noFill/>
+          <a:ln/>
+        </p:spPr>
+        <p:txBody>
+          <a:bodyPr wrap="square" lIns="0" tIns="0" rIns="0" bIns="0" rtlCol="0" anchor="t"/>
+          <a:lstStyle/>
+          <a:p>
+            <a:pPr indent="0" marL="0">
+              <a:buNone/>
+            </a:pPr>
+            <a:r>
+              <a:rPr lang="en-US" sz="2800" b="1" dirty="0">
                 <a:solidFill>
                   <a:srgbClr val="2563EB"/>
                 </a:solidFill>
               </a:rPr>
-              <a:t>Partner price on request</a:t>
-            </a:r>
-            <a:endParaRPr lang="en-US" sz="1200" dirty="0"/>
-          </a:p>
-        </p:txBody>
-      </p:sp>
-      <p:sp>
-        <p:nvSpPr>
-          <p:cNvPr id="8" name="Shape 6"/>
+              <a:t>₹2,999</a:t>
+            </a:r>
+            <a:endParaRPr lang="en-US" sz="2800" dirty="0"/>
+          </a:p>
+        </p:txBody>
+      </p:sp>
+      <p:sp>
+        <p:nvSpPr>
+          <p:cNvPr id="8" name="Text 6"/>
+          <p:cNvSpPr txBox="1"/>
+          <p:nvPr/>
+        </p:nvSpPr>
+        <p:spPr>
+          <a:xfrm>
+            <a:off x="658368" y="3767328"/>
+            <a:ext cx="2240280" cy="228600"/>
+          </a:xfrm>
+          <a:prstGeom prst="rect">
+            <a:avLst/>
+          </a:prstGeom>
+          <a:noFill/>
+          <a:ln/>
+        </p:spPr>
+        <p:txBody>
+          <a:bodyPr wrap="square" lIns="0" tIns="0" rIns="0" bIns="0" rtlCol="0" anchor="t"/>
+          <a:lstStyle/>
+          <a:p>
+            <a:pPr indent="0" marL="0">
+              <a:buNone/>
+            </a:pPr>
+            <a:r>
+              <a:rPr lang="en-US" sz="1100" b="1" dirty="0">
+                <a:solidFill>
+                  <a:srgbClr val="1B2A4A"/>
+                </a:solidFill>
+              </a:rPr>
+              <a:t>Gym-partner members ₹2,699</a:t>
+            </a:r>
+            <a:endParaRPr lang="en-US" sz="1100" dirty="0"/>
+          </a:p>
+        </p:txBody>
+      </p:sp>
+      <p:sp>
+        <p:nvSpPr>
+          <p:cNvPr id="9" name="Text 7"/>
+          <p:cNvSpPr txBox="1"/>
+          <p:nvPr/>
+        </p:nvSpPr>
+        <p:spPr>
+          <a:xfrm>
+            <a:off x="658368" y="4023360"/>
+            <a:ext cx="2240280" cy="228600"/>
+          </a:xfrm>
+          <a:prstGeom prst="rect">
+            <a:avLst/>
+          </a:prstGeom>
+          <a:noFill/>
+          <a:ln/>
+        </p:spPr>
+        <p:txBody>
+          <a:bodyPr wrap="square" lIns="0" tIns="0" rIns="0" bIns="0" rtlCol="0" anchor="t"/>
+          <a:lstStyle/>
+          <a:p>
+            <a:pPr indent="0" marL="0">
+              <a:buNone/>
+            </a:pPr>
+            <a:r>
+              <a:rPr lang="en-US" sz="1000" dirty="0">
+                <a:solidFill>
+                  <a:srgbClr val="475569"/>
+                </a:solidFill>
+              </a:rPr>
+              <a:t>Tests bought separately </a:t>
+            </a:r>
+            <a:pPr indent="0" marL="0">
+              <a:buNone/>
+            </a:pPr>
+            <a:r>
+              <a:rPr lang="en-US" sz="1000" strike="sngStrike" dirty="0">
+                <a:solidFill>
+                  <a:srgbClr val="475569"/>
+                </a:solidFill>
+              </a:rPr>
+              <a:t>₹8,800</a:t>
+            </a:r>
+            <a:endParaRPr lang="en-US" sz="1000" dirty="0"/>
+          </a:p>
+        </p:txBody>
+      </p:sp>
+      <p:sp>
+        <p:nvSpPr>
+          <p:cNvPr id="10" name="Shape 8"/>
           <p:cNvSpPr/>
           <p:nvPr/>
         </p:nvSpPr>
         <p:spPr>
           <a:xfrm>
             <a:off x="3246120" y="1051560"/>
-            <a:ext cx="2606040" cy="3520440"/>
+            <a:ext cx="2606040" cy="3310128"/>
           </a:xfrm>
           <a:prstGeom prst="rect">
             <a:avLst/>
@@ -5776,86 +5859,86 @@
       </p:sp>
       <p:sp>
         <p:nvSpPr>
-          <p:cNvPr id="9" name="Text 7"/>
-          <p:cNvSpPr txBox="1"/>
-          <p:nvPr/>
-        </p:nvSpPr>
-        <p:spPr>
-          <a:xfrm>
-            <a:off x="3447288" y="1207008"/>
-            <a:ext cx="2240280" cy="411480"/>
-          </a:xfrm>
-          <a:prstGeom prst="rect">
-            <a:avLst/>
-          </a:prstGeom>
-          <a:noFill/>
-          <a:ln/>
-        </p:spPr>
-        <p:txBody>
-          <a:bodyPr wrap="square" lIns="0" tIns="0" rIns="0" bIns="0" rtlCol="0" anchor="t"/>
-          <a:lstStyle/>
-          <a:p>
-            <a:pPr indent="0" marL="0">
-              <a:buNone/>
-            </a:pPr>
-            <a:r>
-              <a:rPr lang="en-US" sz="2200" b="1" dirty="0">
+          <p:cNvPr id="11" name="Text 9"/>
+          <p:cNvSpPr txBox="1"/>
+          <p:nvPr/>
+        </p:nvSpPr>
+        <p:spPr>
+          <a:xfrm>
+            <a:off x="3447288" y="1188720"/>
+            <a:ext cx="2240280" cy="384048"/>
+          </a:xfrm>
+          <a:prstGeom prst="rect">
+            <a:avLst/>
+          </a:prstGeom>
+          <a:noFill/>
+          <a:ln/>
+        </p:spPr>
+        <p:txBody>
+          <a:bodyPr wrap="square" lIns="0" tIns="0" rIns="0" bIns="0" rtlCol="0" anchor="t"/>
+          <a:lstStyle/>
+          <a:p>
+            <a:pPr indent="0" marL="0">
+              <a:buNone/>
+            </a:pPr>
+            <a:r>
+              <a:rPr lang="en-US" sz="2100" b="1" dirty="0">
                 <a:solidFill>
                   <a:srgbClr val="FFFFFF"/>
                 </a:solidFill>
               </a:rPr>
               <a:t>Performance</a:t>
             </a:r>
-            <a:endParaRPr lang="en-US" sz="2200" dirty="0"/>
-          </a:p>
-        </p:txBody>
-      </p:sp>
-      <p:sp>
-        <p:nvSpPr>
-          <p:cNvPr id="10" name="Text 8"/>
-          <p:cNvSpPr txBox="1"/>
-          <p:nvPr/>
-        </p:nvSpPr>
-        <p:spPr>
-          <a:xfrm>
-            <a:off x="3447288" y="1664208"/>
-            <a:ext cx="2240280" cy="685800"/>
-          </a:xfrm>
-          <a:prstGeom prst="rect">
-            <a:avLst/>
-          </a:prstGeom>
-          <a:noFill/>
-          <a:ln/>
-        </p:spPr>
-        <p:txBody>
-          <a:bodyPr wrap="square" lIns="0" tIns="0" rIns="0" bIns="0" rtlCol="0" anchor="t"/>
-          <a:lstStyle/>
-          <a:p>
-            <a:pPr indent="0" marL="0">
-              <a:buNone/>
-            </a:pPr>
-            <a:r>
-              <a:rPr lang="en-US" sz="1200" i="1" dirty="0">
+            <a:endParaRPr lang="en-US" sz="2100" dirty="0"/>
+          </a:p>
+        </p:txBody>
+      </p:sp>
+      <p:sp>
+        <p:nvSpPr>
+          <p:cNvPr id="12" name="Text 10"/>
+          <p:cNvSpPr txBox="1"/>
+          <p:nvPr/>
+        </p:nvSpPr>
+        <p:spPr>
+          <a:xfrm>
+            <a:off x="3447288" y="1591056"/>
+            <a:ext cx="2240280" cy="566928"/>
+          </a:xfrm>
+          <a:prstGeom prst="rect">
+            <a:avLst/>
+          </a:prstGeom>
+          <a:noFill/>
+          <a:ln/>
+        </p:spPr>
+        <p:txBody>
+          <a:bodyPr wrap="square" lIns="0" tIns="0" rIns="0" bIns="0" rtlCol="0" anchor="t"/>
+          <a:lstStyle/>
+          <a:p>
+            <a:pPr indent="0" marL="0">
+              <a:buNone/>
+            </a:pPr>
+            <a:r>
+              <a:rPr lang="en-US" sz="1100" i="1" dirty="0">
                 <a:solidFill>
                   <a:srgbClr val="E1EBFF"/>
                 </a:solidFill>
               </a:rPr>
               <a:t>Regular lifters, runners, members on a cut or bulk</a:t>
             </a:r>
-            <a:endParaRPr lang="en-US" sz="1200" dirty="0"/>
-          </a:p>
-        </p:txBody>
-      </p:sp>
-      <p:sp>
-        <p:nvSpPr>
-          <p:cNvPr id="11" name="Text 9"/>
-          <p:cNvSpPr txBox="1"/>
-          <p:nvPr/>
-        </p:nvSpPr>
-        <p:spPr>
-          <a:xfrm>
-            <a:off x="3447288" y="2377440"/>
-            <a:ext cx="2240280" cy="1600200"/>
+            <a:endParaRPr lang="en-US" sz="1100" dirty="0"/>
+          </a:p>
+        </p:txBody>
+      </p:sp>
+      <p:sp>
+        <p:nvSpPr>
+          <p:cNvPr id="13" name="Text 11"/>
+          <p:cNvSpPr txBox="1"/>
+          <p:nvPr/>
+        </p:nvSpPr>
+        <p:spPr>
+          <a:xfrm>
+            <a:off x="3447288" y="2194560"/>
+            <a:ext cx="2240280" cy="1234440"/>
           </a:xfrm>
           <a:prstGeom prst="rect">
             <a:avLst/>
@@ -5869,123 +5952,206 @@
           <a:p>
             <a:pPr marL="342900" indent="-342900">
               <a:spcAft>
-                <a:spcPts val="400"/>
+                <a:spcPts val="300"/>
               </a:spcAft>
               <a:buSzPct val="100000"/>
               <a:buChar char="•"/>
             </a:pPr>
             <a:r>
-              <a:rPr lang="en-US" sz="1300" dirty="0">
+              <a:rPr lang="en-US" sz="1200" dirty="0">
                 <a:solidFill>
                   <a:srgbClr val="FFFFFF"/>
                 </a:solidFill>
               </a:rPr>
-              <a:t>Everything in Base</a:t>
-            </a:r>
-            <a:endParaRPr lang="en-US" sz="1300" dirty="0"/>
+              <a:t>All of Base</a:t>
+            </a:r>
+            <a:endParaRPr lang="en-US" sz="1200" dirty="0"/>
           </a:p>
           <a:p>
             <a:pPr marL="342900" indent="-342900">
               <a:spcAft>
-                <a:spcPts val="400"/>
+                <a:spcPts val="300"/>
               </a:spcAft>
               <a:buSzPct val="100000"/>
               <a:buChar char="•"/>
             </a:pPr>
             <a:r>
-              <a:rPr lang="en-US" sz="1300" dirty="0">
+              <a:rPr lang="en-US" sz="1200" dirty="0">
                 <a:solidFill>
                   <a:srgbClr val="FFFFFF"/>
                 </a:solidFill>
               </a:rPr>
               <a:t>Apo B, Lp(a), NT-proBNP</a:t>
             </a:r>
-            <a:endParaRPr lang="en-US" sz="1300" dirty="0"/>
+            <a:endParaRPr lang="en-US" sz="1200" dirty="0"/>
           </a:p>
           <a:p>
             <a:pPr marL="342900" indent="-342900">
               <a:spcAft>
-                <a:spcPts val="400"/>
+                <a:spcPts val="300"/>
               </a:spcAft>
               <a:buSzPct val="100000"/>
               <a:buChar char="•"/>
             </a:pPr>
             <a:r>
-              <a:rPr lang="en-US" sz="1300" dirty="0">
+              <a:rPr lang="en-US" sz="1200" dirty="0">
                 <a:solidFill>
                   <a:srgbClr val="FFFFFF"/>
                 </a:solidFill>
               </a:rPr>
-              <a:t>Hormone and full muscle panel</a:t>
-            </a:r>
-            <a:endParaRPr lang="en-US" sz="1300" dirty="0"/>
+              <a:t>Hormone and muscle panel</a:t>
+            </a:r>
+            <a:endParaRPr lang="en-US" sz="1200" dirty="0"/>
           </a:p>
           <a:p>
             <a:pPr marL="342900" indent="-342900">
               <a:spcAft>
-                <a:spcPts val="400"/>
+                <a:spcPts val="300"/>
               </a:spcAft>
               <a:buSzPct val="100000"/>
               <a:buChar char="•"/>
             </a:pPr>
             <a:r>
-              <a:rPr lang="en-US" sz="1300" dirty="0">
+              <a:rPr lang="en-US" sz="1200" dirty="0">
                 <a:solidFill>
                   <a:srgbClr val="FFFFFF"/>
                 </a:solidFill>
               </a:rPr>
-              <a:t>One ultrasound region</a:t>
-            </a:r>
-            <a:endParaRPr lang="en-US" sz="1300" dirty="0"/>
-          </a:p>
-        </p:txBody>
-      </p:sp>
-      <p:sp>
-        <p:nvSpPr>
-          <p:cNvPr id="12" name="Text 10"/>
-          <p:cNvSpPr txBox="1"/>
-          <p:nvPr/>
-        </p:nvSpPr>
-        <p:spPr>
-          <a:xfrm>
-            <a:off x="3447288" y="4160520"/>
-            <a:ext cx="2240280" cy="274320"/>
-          </a:xfrm>
-          <a:prstGeom prst="rect">
-            <a:avLst/>
-          </a:prstGeom>
-          <a:noFill/>
-          <a:ln/>
-        </p:spPr>
-        <p:txBody>
-          <a:bodyPr wrap="square" lIns="0" tIns="0" rIns="0" bIns="0" rtlCol="0" anchor="t"/>
-          <a:lstStyle/>
-          <a:p>
-            <a:pPr indent="0" marL="0">
-              <a:buNone/>
-            </a:pPr>
-            <a:r>
-              <a:rPr lang="en-US" sz="1200" b="1" dirty="0">
+              <a:t>1 ultrasound region</a:t>
+            </a:r>
+            <a:endParaRPr lang="en-US" sz="1200" dirty="0"/>
+          </a:p>
+        </p:txBody>
+      </p:sp>
+      <p:sp>
+        <p:nvSpPr>
+          <p:cNvPr id="14" name="Text 12"/>
+          <p:cNvSpPr txBox="1"/>
+          <p:nvPr/>
+        </p:nvSpPr>
+        <p:spPr>
+          <a:xfrm>
+            <a:off x="3447288" y="3291840"/>
+            <a:ext cx="2240280" cy="457200"/>
+          </a:xfrm>
+          <a:prstGeom prst="rect">
+            <a:avLst/>
+          </a:prstGeom>
+          <a:noFill/>
+          <a:ln/>
+        </p:spPr>
+        <p:txBody>
+          <a:bodyPr wrap="square" lIns="0" tIns="0" rIns="0" bIns="0" rtlCol="0" anchor="t"/>
+          <a:lstStyle/>
+          <a:p>
+            <a:pPr indent="0" marL="0">
+              <a:buNone/>
+            </a:pPr>
+            <a:r>
+              <a:rPr lang="en-US" sz="2800" b="1" dirty="0">
                 <a:solidFill>
                   <a:srgbClr val="FFFFFF"/>
                 </a:solidFill>
               </a:rPr>
-              <a:t>Partner price on request</a:t>
-            </a:r>
-            <a:endParaRPr lang="en-US" sz="1200" dirty="0"/>
-          </a:p>
-        </p:txBody>
-      </p:sp>
-      <p:sp>
-        <p:nvSpPr>
-          <p:cNvPr id="13" name="Shape 11"/>
+              <a:t>₹8,999</a:t>
+            </a:r>
+            <a:endParaRPr lang="en-US" sz="2800" dirty="0"/>
+          </a:p>
+        </p:txBody>
+      </p:sp>
+      <p:sp>
+        <p:nvSpPr>
+          <p:cNvPr id="15" name="Text 13"/>
+          <p:cNvSpPr txBox="1"/>
+          <p:nvPr/>
+        </p:nvSpPr>
+        <p:spPr>
+          <a:xfrm>
+            <a:off x="3447288" y="3767328"/>
+            <a:ext cx="2240280" cy="228600"/>
+          </a:xfrm>
+          <a:prstGeom prst="rect">
+            <a:avLst/>
+          </a:prstGeom>
+          <a:noFill/>
+          <a:ln/>
+        </p:spPr>
+        <p:txBody>
+          <a:bodyPr wrap="square" lIns="0" tIns="0" rIns="0" bIns="0" rtlCol="0" anchor="t"/>
+          <a:lstStyle/>
+          <a:p>
+            <a:pPr indent="0" marL="0">
+              <a:buNone/>
+            </a:pPr>
+            <a:r>
+              <a:rPr lang="en-US" sz="1100" b="1" dirty="0">
+                <a:solidFill>
+                  <a:srgbClr val="FFFFFF"/>
+                </a:solidFill>
+              </a:rPr>
+              <a:t>Gym-partner members ₹8,099</a:t>
+            </a:r>
+            <a:endParaRPr lang="en-US" sz="1100" dirty="0"/>
+          </a:p>
+        </p:txBody>
+      </p:sp>
+      <p:sp>
+        <p:nvSpPr>
+          <p:cNvPr id="16" name="Text 14"/>
+          <p:cNvSpPr txBox="1"/>
+          <p:nvPr/>
+        </p:nvSpPr>
+        <p:spPr>
+          <a:xfrm>
+            <a:off x="3447288" y="4023360"/>
+            <a:ext cx="2240280" cy="228600"/>
+          </a:xfrm>
+          <a:prstGeom prst="rect">
+            <a:avLst/>
+          </a:prstGeom>
+          <a:noFill/>
+          <a:ln/>
+        </p:spPr>
+        <p:txBody>
+          <a:bodyPr wrap="square" lIns="0" tIns="0" rIns="0" bIns="0" rtlCol="0" anchor="t"/>
+          <a:lstStyle/>
+          <a:p>
+            <a:pPr indent="0" marL="0">
+              <a:buNone/>
+            </a:pPr>
+            <a:r>
+              <a:rPr lang="en-US" sz="1000" dirty="0">
+                <a:solidFill>
+                  <a:srgbClr val="E1EBFF"/>
+                </a:solidFill>
+              </a:rPr>
+              <a:t>Tests bought separately </a:t>
+            </a:r>
+            <a:pPr indent="0" marL="0">
+              <a:buNone/>
+            </a:pPr>
+            <a:r>
+              <a:rPr lang="en-US" sz="1000" strike="sngStrike" dirty="0">
+                <a:solidFill>
+                  <a:srgbClr val="E1EBFF"/>
+                </a:solidFill>
+              </a:rPr>
+              <a:t>₹29,000</a:t>
+            </a:r>
+            <a:endParaRPr lang="en-US" sz="1000" dirty="0"/>
+          </a:p>
+        </p:txBody>
+      </p:sp>
+      <p:sp>
+        <p:nvSpPr>
+          <p:cNvPr id="17" name="Shape 15"/>
           <p:cNvSpPr/>
           <p:nvPr/>
         </p:nvSpPr>
         <p:spPr>
           <a:xfrm>
             <a:off x="6035040" y="1051560"/>
-            <a:ext cx="2606040" cy="3520440"/>
+            <a:ext cx="2606040" cy="3310128"/>
           </a:xfrm>
           <a:prstGeom prst="rect">
             <a:avLst/>
@@ -6003,86 +6169,86 @@
       </p:sp>
       <p:sp>
         <p:nvSpPr>
-          <p:cNvPr id="14" name="Text 12"/>
-          <p:cNvSpPr txBox="1"/>
-          <p:nvPr/>
-        </p:nvSpPr>
-        <p:spPr>
-          <a:xfrm>
-            <a:off x="6236208" y="1207008"/>
-            <a:ext cx="2240280" cy="411480"/>
-          </a:xfrm>
-          <a:prstGeom prst="rect">
-            <a:avLst/>
-          </a:prstGeom>
-          <a:noFill/>
-          <a:ln/>
-        </p:spPr>
-        <p:txBody>
-          <a:bodyPr wrap="square" lIns="0" tIns="0" rIns="0" bIns="0" rtlCol="0" anchor="t"/>
-          <a:lstStyle/>
-          <a:p>
-            <a:pPr indent="0" marL="0">
-              <a:buNone/>
-            </a:pPr>
-            <a:r>
-              <a:rPr lang="en-US" sz="2200" b="1" dirty="0">
+          <p:cNvPr id="18" name="Text 16"/>
+          <p:cNvSpPr txBox="1"/>
+          <p:nvPr/>
+        </p:nvSpPr>
+        <p:spPr>
+          <a:xfrm>
+            <a:off x="6236208" y="1188720"/>
+            <a:ext cx="2240280" cy="384048"/>
+          </a:xfrm>
+          <a:prstGeom prst="rect">
+            <a:avLst/>
+          </a:prstGeom>
+          <a:noFill/>
+          <a:ln/>
+        </p:spPr>
+        <p:txBody>
+          <a:bodyPr wrap="square" lIns="0" tIns="0" rIns="0" bIns="0" rtlCol="0" anchor="t"/>
+          <a:lstStyle/>
+          <a:p>
+            <a:pPr indent="0" marL="0">
+              <a:buNone/>
+            </a:pPr>
+            <a:r>
+              <a:rPr lang="en-US" sz="2100" b="1" dirty="0">
                 <a:solidFill>
                   <a:srgbClr val="FFFFFF"/>
                 </a:solidFill>
               </a:rPr>
               <a:t>Elite</a:t>
             </a:r>
-            <a:endParaRPr lang="en-US" sz="2200" dirty="0"/>
-          </a:p>
-        </p:txBody>
-      </p:sp>
-      <p:sp>
-        <p:nvSpPr>
-          <p:cNvPr id="15" name="Text 13"/>
-          <p:cNvSpPr txBox="1"/>
-          <p:nvPr/>
-        </p:nvSpPr>
-        <p:spPr>
-          <a:xfrm>
-            <a:off x="6236208" y="1664208"/>
-            <a:ext cx="2240280" cy="685800"/>
-          </a:xfrm>
-          <a:prstGeom prst="rect">
-            <a:avLst/>
-          </a:prstGeom>
-          <a:noFill/>
-          <a:ln/>
-        </p:spPr>
-        <p:txBody>
-          <a:bodyPr wrap="square" lIns="0" tIns="0" rIns="0" bIns="0" rtlCol="0" anchor="t"/>
-          <a:lstStyle/>
-          <a:p>
-            <a:pPr indent="0" marL="0">
-              <a:buNone/>
-            </a:pPr>
-            <a:r>
-              <a:rPr lang="en-US" sz="1200" i="1" dirty="0">
+            <a:endParaRPr lang="en-US" sz="2100" dirty="0"/>
+          </a:p>
+        </p:txBody>
+      </p:sp>
+      <p:sp>
+        <p:nvSpPr>
+          <p:cNvPr id="19" name="Text 17"/>
+          <p:cNvSpPr txBox="1"/>
+          <p:nvPr/>
+        </p:nvSpPr>
+        <p:spPr>
+          <a:xfrm>
+            <a:off x="6236208" y="1591056"/>
+            <a:ext cx="2240280" cy="566928"/>
+          </a:xfrm>
+          <a:prstGeom prst="rect">
+            <a:avLst/>
+          </a:prstGeom>
+          <a:noFill/>
+          <a:ln/>
+        </p:spPr>
+        <p:txBody>
+          <a:bodyPr wrap="square" lIns="0" tIns="0" rIns="0" bIns="0" rtlCol="0" anchor="t"/>
+          <a:lstStyle/>
+          <a:p>
+            <a:pPr indent="0" marL="0">
+              <a:buNone/>
+            </a:pPr>
+            <a:r>
+              <a:rPr lang="en-US" sz="1100" i="1" dirty="0">
                 <a:solidFill>
                   <a:srgbClr val="C9D8F5"/>
                 </a:solidFill>
               </a:rPr>
-              <a:t>Competitors, bodybuilders, members over 35 starting high-intensity work</a:t>
-            </a:r>
-            <a:endParaRPr lang="en-US" sz="1200" dirty="0"/>
-          </a:p>
-        </p:txBody>
-      </p:sp>
-      <p:sp>
-        <p:nvSpPr>
-          <p:cNvPr id="16" name="Text 14"/>
-          <p:cNvSpPr txBox="1"/>
-          <p:nvPr/>
-        </p:nvSpPr>
-        <p:spPr>
-          <a:xfrm>
-            <a:off x="6236208" y="2377440"/>
-            <a:ext cx="2240280" cy="1600200"/>
+              <a:t>Competitors, bodybuilders, over-35s starting high-intensity work</a:t>
+            </a:r>
+            <a:endParaRPr lang="en-US" sz="1100" dirty="0"/>
+          </a:p>
+        </p:txBody>
+      </p:sp>
+      <p:sp>
+        <p:nvSpPr>
+          <p:cNvPr id="20" name="Text 18"/>
+          <p:cNvSpPr txBox="1"/>
+          <p:nvPr/>
+        </p:nvSpPr>
+        <p:spPr>
+          <a:xfrm>
+            <a:off x="6236208" y="2194560"/>
+            <a:ext cx="2240280" cy="1234440"/>
           </a:xfrm>
           <a:prstGeom prst="rect">
             <a:avLst/>
@@ -6096,110 +6262,229 @@
           <a:p>
             <a:pPr marL="342900" indent="-342900">
               <a:spcAft>
-                <a:spcPts val="400"/>
+                <a:spcPts val="300"/>
               </a:spcAft>
               <a:buSzPct val="100000"/>
               <a:buChar char="•"/>
             </a:pPr>
             <a:r>
-              <a:rPr lang="en-US" sz="1300" dirty="0">
+              <a:rPr lang="en-US" sz="1200" dirty="0">
                 <a:solidFill>
                   <a:srgbClr val="FFFFFF"/>
                 </a:solidFill>
               </a:rPr>
-              <a:t>Everything in Performance</a:t>
-            </a:r>
-            <a:endParaRPr lang="en-US" sz="1300" dirty="0"/>
+              <a:t>All of Performance</a:t>
+            </a:r>
+            <a:endParaRPr lang="en-US" sz="1200" dirty="0"/>
           </a:p>
           <a:p>
             <a:pPr marL="342900" indent="-342900">
               <a:spcAft>
-                <a:spcPts val="400"/>
+                <a:spcPts val="300"/>
               </a:spcAft>
               <a:buSzPct val="100000"/>
               <a:buChar char="•"/>
             </a:pPr>
             <a:r>
-              <a:rPr lang="en-US" sz="1300" dirty="0">
+              <a:rPr lang="en-US" sz="1200" dirty="0">
                 <a:solidFill>
                   <a:srgbClr val="FFFFFF"/>
                 </a:solidFill>
               </a:rPr>
               <a:t>Treadmill stress test</a:t>
             </a:r>
-            <a:endParaRPr lang="en-US" sz="1300" dirty="0"/>
+            <a:endParaRPr lang="en-US" sz="1200" dirty="0"/>
           </a:p>
           <a:p>
             <a:pPr marL="342900" indent="-342900">
               <a:spcAft>
-                <a:spcPts val="400"/>
+                <a:spcPts val="300"/>
               </a:spcAft>
               <a:buSzPct val="100000"/>
               <a:buChar char="•"/>
             </a:pPr>
             <a:r>
-              <a:rPr lang="en-US" sz="1300" dirty="0">
+              <a:rPr lang="en-US" sz="1200" dirty="0">
                 <a:solidFill>
                   <a:srgbClr val="FFFFFF"/>
                 </a:solidFill>
               </a:rPr>
               <a:t>hs-troponin, IGF-1, cortisol</a:t>
             </a:r>
-            <a:endParaRPr lang="en-US" sz="1300" dirty="0"/>
+            <a:endParaRPr lang="en-US" sz="1200" dirty="0"/>
           </a:p>
           <a:p>
             <a:pPr marL="342900" indent="-342900">
               <a:spcAft>
-                <a:spcPts val="400"/>
+                <a:spcPts val="300"/>
               </a:spcAft>
               <a:buSzPct val="100000"/>
               <a:buChar char="•"/>
             </a:pPr>
             <a:r>
-              <a:rPr lang="en-US" sz="1300" dirty="0">
+              <a:rPr lang="en-US" sz="1200" dirty="0">
                 <a:solidFill>
                   <a:srgbClr val="FFFFFF"/>
                 </a:solidFill>
               </a:rPr>
-              <a:t>Up to three ultrasound regions</a:t>
-            </a:r>
-            <a:endParaRPr lang="en-US" sz="1300" dirty="0"/>
-          </a:p>
-        </p:txBody>
-      </p:sp>
-      <p:sp>
-        <p:nvSpPr>
-          <p:cNvPr id="17" name="Text 15"/>
-          <p:cNvSpPr txBox="1"/>
-          <p:nvPr/>
-        </p:nvSpPr>
-        <p:spPr>
-          <a:xfrm>
-            <a:off x="6236208" y="4160520"/>
-            <a:ext cx="2240280" cy="274320"/>
-          </a:xfrm>
-          <a:prstGeom prst="rect">
-            <a:avLst/>
-          </a:prstGeom>
-          <a:noFill/>
-          <a:ln/>
-        </p:spPr>
-        <p:txBody>
-          <a:bodyPr wrap="square" lIns="0" tIns="0" rIns="0" bIns="0" rtlCol="0" anchor="t"/>
-          <a:lstStyle/>
-          <a:p>
-            <a:pPr indent="0" marL="0">
-              <a:buNone/>
-            </a:pPr>
-            <a:r>
-              <a:rPr lang="en-US" sz="1200" b="1" dirty="0">
+              <a:t>Up to 3 ultrasound regions</a:t>
+            </a:r>
+            <a:endParaRPr lang="en-US" sz="1200" dirty="0"/>
+          </a:p>
+        </p:txBody>
+      </p:sp>
+      <p:sp>
+        <p:nvSpPr>
+          <p:cNvPr id="21" name="Text 19"/>
+          <p:cNvSpPr txBox="1"/>
+          <p:nvPr/>
+        </p:nvSpPr>
+        <p:spPr>
+          <a:xfrm>
+            <a:off x="6236208" y="3291840"/>
+            <a:ext cx="2240280" cy="457200"/>
+          </a:xfrm>
+          <a:prstGeom prst="rect">
+            <a:avLst/>
+          </a:prstGeom>
+          <a:noFill/>
+          <a:ln/>
+        </p:spPr>
+        <p:txBody>
+          <a:bodyPr wrap="square" lIns="0" tIns="0" rIns="0" bIns="0" rtlCol="0" anchor="t"/>
+          <a:lstStyle/>
+          <a:p>
+            <a:pPr indent="0" marL="0">
+              <a:buNone/>
+            </a:pPr>
+            <a:r>
+              <a:rPr lang="en-US" sz="2800" b="1" dirty="0">
                 <a:solidFill>
                   <a:srgbClr val="22C55E"/>
                 </a:solidFill>
               </a:rPr>
-              <a:t>Partner price on request</a:t>
-            </a:r>
-            <a:endParaRPr lang="en-US" sz="1200" dirty="0"/>
+              <a:t>₹12,999</a:t>
+            </a:r>
+            <a:endParaRPr lang="en-US" sz="2800" dirty="0"/>
+          </a:p>
+        </p:txBody>
+      </p:sp>
+      <p:sp>
+        <p:nvSpPr>
+          <p:cNvPr id="22" name="Text 20"/>
+          <p:cNvSpPr txBox="1"/>
+          <p:nvPr/>
+        </p:nvSpPr>
+        <p:spPr>
+          <a:xfrm>
+            <a:off x="6236208" y="3767328"/>
+            <a:ext cx="2240280" cy="228600"/>
+          </a:xfrm>
+          <a:prstGeom prst="rect">
+            <a:avLst/>
+          </a:prstGeom>
+          <a:noFill/>
+          <a:ln/>
+        </p:spPr>
+        <p:txBody>
+          <a:bodyPr wrap="square" lIns="0" tIns="0" rIns="0" bIns="0" rtlCol="0" anchor="t"/>
+          <a:lstStyle/>
+          <a:p>
+            <a:pPr indent="0" marL="0">
+              <a:buNone/>
+            </a:pPr>
+            <a:r>
+              <a:rPr lang="en-US" sz="1100" b="1" dirty="0">
+                <a:solidFill>
+                  <a:srgbClr val="FFFFFF"/>
+                </a:solidFill>
+              </a:rPr>
+              <a:t>Gym-partner members ₹11,699</a:t>
+            </a:r>
+            <a:endParaRPr lang="en-US" sz="1100" dirty="0"/>
+          </a:p>
+        </p:txBody>
+      </p:sp>
+      <p:sp>
+        <p:nvSpPr>
+          <p:cNvPr id="23" name="Text 21"/>
+          <p:cNvSpPr txBox="1"/>
+          <p:nvPr/>
+        </p:nvSpPr>
+        <p:spPr>
+          <a:xfrm>
+            <a:off x="6236208" y="4023360"/>
+            <a:ext cx="2240280" cy="228600"/>
+          </a:xfrm>
+          <a:prstGeom prst="rect">
+            <a:avLst/>
+          </a:prstGeom>
+          <a:noFill/>
+          <a:ln/>
+        </p:spPr>
+        <p:txBody>
+          <a:bodyPr wrap="square" lIns="0" tIns="0" rIns="0" bIns="0" rtlCol="0" anchor="t"/>
+          <a:lstStyle/>
+          <a:p>
+            <a:pPr indent="0" marL="0">
+              <a:buNone/>
+            </a:pPr>
+            <a:r>
+              <a:rPr lang="en-US" sz="1000" dirty="0">
+                <a:solidFill>
+                  <a:srgbClr val="C9D8F5"/>
+                </a:solidFill>
+              </a:rPr>
+              <a:t>Tests bought separately </a:t>
+            </a:r>
+            <a:pPr indent="0" marL="0">
+              <a:buNone/>
+            </a:pPr>
+            <a:r>
+              <a:rPr lang="en-US" sz="1000" strike="sngStrike" dirty="0">
+                <a:solidFill>
+                  <a:srgbClr val="C9D8F5"/>
+                </a:solidFill>
+              </a:rPr>
+              <a:t>₹40,700</a:t>
+            </a:r>
+            <a:endParaRPr lang="en-US" sz="1000" dirty="0"/>
+          </a:p>
+        </p:txBody>
+      </p:sp>
+      <p:sp>
+        <p:nvSpPr>
+          <p:cNvPr id="24" name="Text 22"/>
+          <p:cNvSpPr txBox="1"/>
+          <p:nvPr/>
+        </p:nvSpPr>
+        <p:spPr>
+          <a:xfrm>
+            <a:off x="457200" y="4462272"/>
+            <a:ext cx="8229600" cy="201168"/>
+          </a:xfrm>
+          <a:prstGeom prst="rect">
+            <a:avLst/>
+          </a:prstGeom>
+          <a:noFill/>
+          <a:ln/>
+        </p:spPr>
+        <p:txBody>
+          <a:bodyPr wrap="square" lIns="0" tIns="0" rIns="0" bIns="0" rtlCol="0" anchor="t"/>
+          <a:lstStyle/>
+          <a:p>
+            <a:pPr indent="0" marL="0">
+              <a:buNone/>
+            </a:pPr>
+            <a:r>
+              <a:rPr lang="en-US" sz="1000" dirty="0">
+                <a:solidFill>
+                  <a:srgbClr val="475569"/>
+                </a:solidFill>
+              </a:rPr>
+              <a:t>Add-ons: Urine drug screen ₹1,999   |   Extra ultrasound region ₹999</a:t>
+            </a:r>
+            <a:endParaRPr lang="en-US" sz="1000" dirty="0"/>
           </a:p>
         </p:txBody>
       </p:sp>

</xml_diff>